<commit_message>
added lecture 21 on DNN
</commit_message>
<xml_diff>
--- a/ECE1390_Lecture21.pptx
+++ b/ECE1390_Lecture21.pptx
@@ -12616,7 +12616,7 @@
         <p:spPr>
           <a:xfrm>
             <a:off x="838199" y="5189945"/>
-            <a:ext cx="8395741" cy="1200329"/>
+            <a:ext cx="8395741" cy="1477328"/>
           </a:xfrm>
           <a:prstGeom prst="rect">
             <a:avLst/>
@@ -12693,6 +12693,15 @@
             </a:r>
           </a:p>
           <a:p>
+            <a:endParaRPr lang="en-US" b="0" i="0" dirty="0">
+              <a:solidFill>
+                <a:srgbClr val="000000"/>
+              </a:solidFill>
+              <a:effectLst/>
+              <a:latin typeface="Menlo" panose="020B0609030804020204" pitchFamily="49" charset="0"/>
+            </a:endParaRPr>
+          </a:p>
+          <a:p>
             <a:r>
               <a:rPr lang="en-US" b="0" i="0" dirty="0">
                 <a:solidFill>
@@ -12727,6 +12736,36 @@
           </a:p>
         </p:txBody>
       </p:sp>
+      <p:pic>
+        <p:nvPicPr>
+          <p:cNvPr id="8" name="Picture 7">
+            <a:extLst>
+              <a:ext uri="{FF2B5EF4-FFF2-40B4-BE49-F238E27FC236}">
+                <a16:creationId xmlns:a16="http://schemas.microsoft.com/office/drawing/2014/main" id="{0A96E74C-DB6F-CD55-C390-6F09A52BBBAD}"/>
+              </a:ext>
+            </a:extLst>
+          </p:cNvPr>
+          <p:cNvPicPr>
+            <a:picLocks noChangeAspect="1"/>
+          </p:cNvPicPr>
+          <p:nvPr/>
+        </p:nvPicPr>
+        <p:blipFill>
+          <a:blip r:embed="rId2"/>
+          <a:stretch>
+            <a:fillRect/>
+          </a:stretch>
+        </p:blipFill>
+        <p:spPr>
+          <a:xfrm>
+            <a:off x="7257321" y="681036"/>
+            <a:ext cx="4547266" cy="3546189"/>
+          </a:xfrm>
+          <a:prstGeom prst="rect">
+            <a:avLst/>
+          </a:prstGeom>
+        </p:spPr>
+      </p:pic>
     </p:spTree>
     <p:extLst>
       <p:ext uri="{BB962C8B-B14F-4D97-AF65-F5344CB8AC3E}">

</xml_diff>